<commit_message>
Use Inter as the only font in templates, scripts and skills
Replace Space Grotesk with Inter in the Word and PowerPoint templates,
all build scripts and the keynote skill. Bundle Inter and Space Mono
files in assets/fonts so the AWS guide build no longer needs installed fonts.

Co-Authored-By: Claude Sonnet 5.5 <noreply@anthropic.com>
</commit_message>
<xml_diff>
--- a/PPT Template.pptx
+++ b/PPT Template.pptx
@@ -617,10 +617,10 @@
               <a:solidFill>
                 <a:schemeClr val="lt1"/>
               </a:solidFill>
-              <a:latin typeface="Montserrat"/>
-              <a:ea typeface="Montserrat"/>
-              <a:cs typeface="Montserrat"/>
-              <a:sym typeface="Montserrat"/>
+              <a:latin typeface="Inter"/>
+              <a:ea typeface="Inter"/>
+              <a:cs typeface="Inter"/>
+              <a:sym typeface="Inter"/>
             </a:endParaRPr>
           </a:p>
         </p:txBody>
@@ -960,10 +960,10 @@
               <a:solidFill>
                 <a:schemeClr val="lt1"/>
               </a:solidFill>
-              <a:latin typeface="Montserrat"/>
-              <a:ea typeface="Montserrat"/>
-              <a:cs typeface="Montserrat"/>
-              <a:sym typeface="Montserrat"/>
+              <a:latin typeface="Inter"/>
+              <a:ea typeface="Inter"/>
+              <a:cs typeface="Inter"/>
+              <a:sym typeface="Inter"/>
             </a:endParaRPr>
           </a:p>
         </p:txBody>
@@ -1696,10 +1696,10 @@
                   <a:solidFill>
                     <a:srgbClr val="FFFFFF"/>
                   </a:solidFill>
-                  <a:latin typeface="Space Grotesk Medium"/>
-                  <a:ea typeface="Space Grotesk Medium"/>
-                  <a:cs typeface="Space Grotesk Medium"/>
-                  <a:sym typeface="Space Grotesk Medium"/>
+                  <a:latin typeface="Inter"/>
+                  <a:ea typeface="Inter"/>
+                  <a:cs typeface="Inter"/>
+                  <a:sym typeface="Inter"/>
                 </a:rPr>
                 <a:t>Certified by</a:t>
               </a:r>
@@ -1707,10 +1707,10 @@
                 <a:solidFill>
                   <a:srgbClr val="FFFFFF"/>
                 </a:solidFill>
-                <a:latin typeface="Space Grotesk Medium"/>
-                <a:ea typeface="Space Grotesk Medium"/>
-                <a:cs typeface="Space Grotesk Medium"/>
-                <a:sym typeface="Space Grotesk Medium"/>
+                <a:latin typeface="Inter"/>
+                <a:ea typeface="Inter"/>
+                <a:cs typeface="Inter"/>
+                <a:sym typeface="Inter"/>
               </a:endParaRPr>
             </a:p>
           </p:txBody>
@@ -1863,10 +1863,10 @@
                 <a:solidFill>
                   <a:schemeClr val="lt1"/>
                 </a:solidFill>
-                <a:latin typeface="Space Grotesk"/>
-                <a:ea typeface="Space Grotesk"/>
-                <a:cs typeface="Space Grotesk"/>
-                <a:sym typeface="Space Grotesk"/>
+                <a:latin typeface="Inter"/>
+                <a:ea typeface="Inter"/>
+                <a:cs typeface="Inter"/>
+                <a:sym typeface="Inter"/>
               </a:rPr>
               <a:t>www.AccuKnox.com</a:t>
             </a:r>
@@ -1874,10 +1874,10 @@
               <a:solidFill>
                 <a:schemeClr val="lt1"/>
               </a:solidFill>
-              <a:latin typeface="Space Grotesk"/>
-              <a:ea typeface="Space Grotesk"/>
-              <a:cs typeface="Space Grotesk"/>
-              <a:sym typeface="Space Grotesk"/>
+              <a:latin typeface="Inter"/>
+              <a:ea typeface="Inter"/>
+              <a:cs typeface="Inter"/>
+              <a:sym typeface="Inter"/>
             </a:endParaRPr>
           </a:p>
         </p:txBody>
@@ -2172,10 +2172,10 @@
               <a:solidFill>
                 <a:schemeClr val="lt1"/>
               </a:solidFill>
-              <a:latin typeface="Montserrat"/>
-              <a:ea typeface="Montserrat"/>
-              <a:cs typeface="Montserrat"/>
-              <a:sym typeface="Montserrat"/>
+              <a:latin typeface="Inter"/>
+              <a:ea typeface="Inter"/>
+              <a:cs typeface="Inter"/>
+              <a:sym typeface="Inter"/>
             </a:endParaRPr>
           </a:p>
         </p:txBody>
@@ -2459,10 +2459,10 @@
               <a:solidFill>
                 <a:schemeClr val="lt1"/>
               </a:solidFill>
-              <a:latin typeface="Montserrat"/>
-              <a:ea typeface="Montserrat"/>
-              <a:cs typeface="Montserrat"/>
-              <a:sym typeface="Montserrat"/>
+              <a:latin typeface="Inter"/>
+              <a:ea typeface="Inter"/>
+              <a:cs typeface="Inter"/>
+              <a:sym typeface="Inter"/>
             </a:endParaRPr>
           </a:p>
         </p:txBody>
@@ -3453,8 +3453,8 @@
                     <a:tint val="82000"/>
                   </a:schemeClr>
                 </a:solidFill>
-                <a:latin typeface="Space Grotesk Light" pitchFamily="2" charset="77"/>
-                <a:cs typeface="Space Grotesk Light" pitchFamily="2" charset="77"/>
+                <a:latin typeface="Inter" pitchFamily="2" charset="77"/>
+                <a:cs typeface="Inter" pitchFamily="2" charset="77"/>
               </a:defRPr>
             </a:lvl1pPr>
           </a:lstStyle>
@@ -3497,8 +3497,8 @@
                     <a:tint val="82000"/>
                   </a:schemeClr>
                 </a:solidFill>
-                <a:latin typeface="Space Grotesk Light" pitchFamily="2" charset="77"/>
-                <a:cs typeface="Space Grotesk Light" pitchFamily="2" charset="77"/>
+                <a:latin typeface="Inter" pitchFamily="2" charset="77"/>
+                <a:cs typeface="Inter" pitchFamily="2" charset="77"/>
               </a:defRPr>
             </a:lvl1pPr>
           </a:lstStyle>
@@ -3536,8 +3536,8 @@
                     <a:tint val="82000"/>
                   </a:schemeClr>
                 </a:solidFill>
-                <a:latin typeface="Space Grotesk Light" pitchFamily="2" charset="77"/>
-                <a:cs typeface="Space Grotesk Light" pitchFamily="2" charset="77"/>
+                <a:latin typeface="Inter" pitchFamily="2" charset="77"/>
+                <a:cs typeface="Inter" pitchFamily="2" charset="77"/>
               </a:defRPr>
             </a:lvl1pPr>
           </a:lstStyle>
@@ -3586,9 +3586,9 @@
           <a:solidFill>
             <a:schemeClr val="tx1"/>
           </a:solidFill>
-          <a:latin typeface="Space Grotesk Medium" pitchFamily="2" charset="77"/>
+          <a:latin typeface="Inter" pitchFamily="2" charset="77"/>
           <a:ea typeface="+mj-ea"/>
-          <a:cs typeface="Space Grotesk Medium" pitchFamily="2" charset="77"/>
+          <a:cs typeface="Inter" pitchFamily="2" charset="77"/>
         </a:defRPr>
       </a:lvl1pPr>
     </p:titleStyle>
@@ -3606,9 +3606,9 @@
           <a:solidFill>
             <a:schemeClr val="tx1"/>
           </a:solidFill>
-          <a:latin typeface="Space Grotesk Light" pitchFamily="2" charset="77"/>
+          <a:latin typeface="Inter" pitchFamily="2" charset="77"/>
           <a:ea typeface="+mn-ea"/>
-          <a:cs typeface="Space Grotesk Light" pitchFamily="2" charset="77"/>
+          <a:cs typeface="Inter" pitchFamily="2" charset="77"/>
         </a:defRPr>
       </a:lvl1pPr>
       <a:lvl2pPr marL="514350" indent="-171450" algn="l" defTabSz="685800" rtl="0" eaLnBrk="1" latinLnBrk="0" hangingPunct="1">
@@ -3624,9 +3624,9 @@
           <a:solidFill>
             <a:schemeClr val="tx1"/>
           </a:solidFill>
-          <a:latin typeface="Space Grotesk Light" pitchFamily="2" charset="77"/>
+          <a:latin typeface="Inter" pitchFamily="2" charset="77"/>
           <a:ea typeface="+mn-ea"/>
-          <a:cs typeface="Space Grotesk Light" pitchFamily="2" charset="77"/>
+          <a:cs typeface="Inter" pitchFamily="2" charset="77"/>
         </a:defRPr>
       </a:lvl2pPr>
       <a:lvl3pPr marL="857250" indent="-171450" algn="l" defTabSz="685800" rtl="0" eaLnBrk="1" latinLnBrk="0" hangingPunct="1">
@@ -3642,9 +3642,9 @@
           <a:solidFill>
             <a:schemeClr val="tx1"/>
           </a:solidFill>
-          <a:latin typeface="Space Grotesk Light" pitchFamily="2" charset="77"/>
+          <a:latin typeface="Inter" pitchFamily="2" charset="77"/>
           <a:ea typeface="+mn-ea"/>
-          <a:cs typeface="Space Grotesk Light" pitchFamily="2" charset="77"/>
+          <a:cs typeface="Inter" pitchFamily="2" charset="77"/>
         </a:defRPr>
       </a:lvl3pPr>
       <a:lvl4pPr marL="1200150" indent="-171450" algn="l" defTabSz="685800" rtl="0" eaLnBrk="1" latinLnBrk="0" hangingPunct="1">
@@ -3660,9 +3660,9 @@
           <a:solidFill>
             <a:schemeClr val="tx1"/>
           </a:solidFill>
-          <a:latin typeface="Space Grotesk Light" pitchFamily="2" charset="77"/>
+          <a:latin typeface="Inter" pitchFamily="2" charset="77"/>
           <a:ea typeface="+mn-ea"/>
-          <a:cs typeface="Space Grotesk Light" pitchFamily="2" charset="77"/>
+          <a:cs typeface="Inter" pitchFamily="2" charset="77"/>
         </a:defRPr>
       </a:lvl4pPr>
       <a:lvl5pPr marL="1543050" indent="-171450" algn="l" defTabSz="685800" rtl="0" eaLnBrk="1" latinLnBrk="0" hangingPunct="1">
@@ -3678,9 +3678,9 @@
           <a:solidFill>
             <a:schemeClr val="tx1"/>
           </a:solidFill>
-          <a:latin typeface="Space Grotesk Light" pitchFamily="2" charset="77"/>
+          <a:latin typeface="Inter" pitchFamily="2" charset="77"/>
           <a:ea typeface="+mn-ea"/>
-          <a:cs typeface="Space Grotesk Light" pitchFamily="2" charset="77"/>
+          <a:cs typeface="Inter" pitchFamily="2" charset="77"/>
         </a:defRPr>
       </a:lvl5pPr>
       <a:lvl6pPr marL="1885950" indent="-171450" algn="l" defTabSz="685800" rtl="0" eaLnBrk="1" latinLnBrk="0" hangingPunct="1">

</xml_diff>